<commit_message>
Increase deck font sizes for readability
Bullets 15-18pt, flow nodes 13.5pt, captions 23pt, section titles 30-38pt;
containers re-measured so nothing overflows.

Co-Authored-By: Claude <noreply@anthropic.com>
Claude-Session: https://claude.ai/code/session_0144pWb7gaUkrE87cb3A7msY
</commit_message>
<xml_diff>
--- a/dist/mundra-portal-walkthrough.pptx
+++ b/dist/mundra-portal-walkthrough.pptx
@@ -2391,8 +2391,8 @@
         </p:nvSpPr>
         <p:spPr>
           <a:xfrm>
-            <a:off x="1261872" y="329184"/>
-            <a:ext cx="10426903" cy="676656"/>
+            <a:off x="1261872" y="274320"/>
+            <a:ext cx="10426903" cy="804672"/>
           </a:xfrm>
           <a:prstGeom prst="rect">
             <a:avLst/>
@@ -2408,7 +2408,7 @@
               <a:buNone/>
             </a:pPr>
             <a:r>
-              <a:rPr lang="en-US" sz="2100" b="1" dirty="0">
+              <a:rPr lang="en-US" sz="2300" b="1" dirty="0">
                 <a:solidFill>
                   <a:srgbClr val="15242E"/>
                 </a:solidFill>
@@ -2418,7 +2418,7 @@
               </a:rPr>
               <a:t>Crew and certificates tracked — warnings before anything expires.</a:t>
             </a:r>
-            <a:endParaRPr lang="en-US" sz="2100" dirty="0"/>
+            <a:endParaRPr lang="en-US" sz="2300" dirty="0"/>
           </a:p>
         </p:txBody>
       </p:sp>
@@ -2430,7 +2430,7 @@
         </p:nvSpPr>
         <p:spPr>
           <a:xfrm>
-            <a:off x="1280160" y="987552"/>
+            <a:off x="1280160" y="1097280"/>
             <a:ext cx="2011680" cy="41148"/>
           </a:xfrm>
           <a:prstGeom prst="rect">
@@ -2458,8 +2458,8 @@
         </p:blipFill>
         <p:spPr>
           <a:xfrm>
-            <a:off x="1706728" y="1143000"/>
-            <a:ext cx="8778240" cy="5486400"/>
+            <a:off x="1779880" y="1261872"/>
+            <a:ext cx="8631936" cy="5394960"/>
           </a:xfrm>
           <a:prstGeom prst="ellipse">
             <a:avLst/>
@@ -2556,8 +2556,8 @@
         </p:nvSpPr>
         <p:spPr>
           <a:xfrm>
-            <a:off x="1261872" y="329184"/>
-            <a:ext cx="10426903" cy="676656"/>
+            <a:off x="1261872" y="274320"/>
+            <a:ext cx="10426903" cy="804672"/>
           </a:xfrm>
           <a:prstGeom prst="rect">
             <a:avLst/>
@@ -2573,7 +2573,7 @@
               <a:buNone/>
             </a:pPr>
             <a:r>
-              <a:rPr lang="en-US" sz="2100" b="1" dirty="0">
+              <a:rPr lang="en-US" sz="2300" b="1" dirty="0">
                 <a:solidFill>
                   <a:srgbClr val="15242E"/>
                 </a:solidFill>
@@ -2583,7 +2583,7 @@
               </a:rPr>
               <a:t>Ask in plain words — it answers from your port’s own records.</a:t>
             </a:r>
-            <a:endParaRPr lang="en-US" sz="2100" dirty="0"/>
+            <a:endParaRPr lang="en-US" sz="2300" dirty="0"/>
           </a:p>
         </p:txBody>
       </p:sp>
@@ -2595,7 +2595,7 @@
         </p:nvSpPr>
         <p:spPr>
           <a:xfrm>
-            <a:off x="1280160" y="987552"/>
+            <a:off x="1280160" y="1097280"/>
             <a:ext cx="2011680" cy="41148"/>
           </a:xfrm>
           <a:prstGeom prst="rect">
@@ -2623,8 +2623,8 @@
         </p:blipFill>
         <p:spPr>
           <a:xfrm>
-            <a:off x="1706728" y="1143000"/>
-            <a:ext cx="8778240" cy="5486400"/>
+            <a:off x="1779880" y="1261872"/>
+            <a:ext cx="8631936" cy="5394960"/>
           </a:xfrm>
           <a:prstGeom prst="ellipse">
             <a:avLst/>
@@ -2721,8 +2721,8 @@
         </p:nvSpPr>
         <p:spPr>
           <a:xfrm>
-            <a:off x="1261872" y="329184"/>
-            <a:ext cx="10426903" cy="676656"/>
+            <a:off x="1261872" y="274320"/>
+            <a:ext cx="10426903" cy="804672"/>
           </a:xfrm>
           <a:prstGeom prst="rect">
             <a:avLst/>
@@ -2738,7 +2738,7 @@
               <a:buNone/>
             </a:pPr>
             <a:r>
-              <a:rPr lang="en-US" sz="2100" b="1" dirty="0">
+              <a:rPr lang="en-US" sz="2300" b="1" dirty="0">
                 <a:solidFill>
                   <a:srgbClr val="15242E"/>
                 </a:solidFill>
@@ -2748,7 +2748,7 @@
               </a:rPr>
               <a:t>Your team controls everything — masters, settings, users.</a:t>
             </a:r>
-            <a:endParaRPr lang="en-US" sz="2100" dirty="0"/>
+            <a:endParaRPr lang="en-US" sz="2300" dirty="0"/>
           </a:p>
         </p:txBody>
       </p:sp>
@@ -2760,7 +2760,7 @@
         </p:nvSpPr>
         <p:spPr>
           <a:xfrm>
-            <a:off x="1280160" y="987552"/>
+            <a:off x="1280160" y="1097280"/>
             <a:ext cx="2011680" cy="41148"/>
           </a:xfrm>
           <a:prstGeom prst="rect">
@@ -2788,8 +2788,8 @@
         </p:blipFill>
         <p:spPr>
           <a:xfrm>
-            <a:off x="1706728" y="1143000"/>
-            <a:ext cx="8778240" cy="5486400"/>
+            <a:off x="1779880" y="1261872"/>
+            <a:ext cx="8631936" cy="5394960"/>
           </a:xfrm>
           <a:prstGeom prst="ellipse">
             <a:avLst/>
@@ -2860,7 +2860,7 @@
               <a:buNone/>
             </a:pPr>
             <a:r>
-              <a:rPr lang="en-US" sz="3400" b="1" dirty="0">
+              <a:rPr lang="en-US" sz="3800" b="1" dirty="0">
                 <a:solidFill>
                   <a:srgbClr val="15242E"/>
                 </a:solidFill>
@@ -2870,7 +2870,7 @@
               </a:rPr>
               <a:t>Why this matters</a:t>
             </a:r>
-            <a:endParaRPr lang="en-US" sz="3400" dirty="0"/>
+            <a:endParaRPr lang="en-US" sz="3800" dirty="0"/>
           </a:p>
         </p:txBody>
       </p:sp>
@@ -2926,7 +2926,7 @@
               <a:buChar char="•"/>
             </a:pPr>
             <a:r>
-              <a:rPr lang="en-US" sz="2000" dirty="0">
+              <a:rPr lang="en-US" sz="2200" dirty="0">
                 <a:solidFill>
                   <a:srgbClr val="2E4450"/>
                 </a:solidFill>
@@ -2936,7 +2936,7 @@
               </a:rPr>
               <a:t>It is working software, not a proposal — you can click it today.</a:t>
             </a:r>
-            <a:endParaRPr lang="en-US" sz="2000" dirty="0"/>
+            <a:endParaRPr lang="en-US" sz="2200" dirty="0"/>
           </a:p>
           <a:p>
             <a:pPr marL="279400" indent="-279400">
@@ -2950,7 +2950,7 @@
               <a:buChar char="•"/>
             </a:pPr>
             <a:r>
-              <a:rPr lang="en-US" sz="2000" dirty="0">
+              <a:rPr lang="en-US" sz="2200" dirty="0">
                 <a:solidFill>
                   <a:srgbClr val="2E4450"/>
                 </a:solidFill>
@@ -2960,7 +2960,7 @@
               </a:rPr>
               <a:t>It is built the way a port actually runs — berths, tides, vessel calls, GST invoices, inspections.</a:t>
             </a:r>
-            <a:endParaRPr lang="en-US" sz="2000" dirty="0"/>
+            <a:endParaRPr lang="en-US" sz="2200" dirty="0"/>
           </a:p>
           <a:p>
             <a:pPr marL="279400" indent="-279400">
@@ -2971,7 +2971,7 @@
               <a:buChar char="•"/>
             </a:pPr>
             <a:r>
-              <a:rPr lang="en-US" sz="2000" dirty="0">
+              <a:rPr lang="en-US" sz="2200" dirty="0">
                 <a:solidFill>
                   <a:srgbClr val="2E4450"/>
                 </a:solidFill>
@@ -2981,7 +2981,7 @@
               </a:rPr>
               <a:t>It can be shaped with your team into a pilot for the areas you choose.</a:t>
             </a:r>
-            <a:endParaRPr lang="en-US" sz="2000" dirty="0"/>
+            <a:endParaRPr lang="en-US" sz="2200" dirty="0"/>
           </a:p>
         </p:txBody>
       </p:sp>
@@ -3327,7 +3327,7 @@
               <a:buNone/>
             </a:pPr>
             <a:r>
-              <a:rPr lang="en-US" sz="3400" b="1" dirty="0">
+              <a:rPr lang="en-US" sz="3800" b="1" dirty="0">
                 <a:solidFill>
                   <a:srgbClr val="15242E"/>
                 </a:solidFill>
@@ -3337,7 +3337,7 @@
               </a:rPr>
               <a:t>What is this?</a:t>
             </a:r>
-            <a:endParaRPr lang="en-US" sz="3400" dirty="0"/>
+            <a:endParaRPr lang="en-US" sz="3800" dirty="0"/>
           </a:p>
         </p:txBody>
       </p:sp>
@@ -3393,7 +3393,7 @@
               <a:buChar char="•"/>
             </a:pPr>
             <a:r>
-              <a:rPr lang="en-US" sz="2000" dirty="0">
+              <a:rPr lang="en-US" sz="2200" dirty="0">
                 <a:solidFill>
                   <a:srgbClr val="2E4450"/>
                 </a:solidFill>
@@ -3403,7 +3403,7 @@
               </a:rPr>
               <a:t>One software where the whole port works — every department, one login.</a:t>
             </a:r>
-            <a:endParaRPr lang="en-US" sz="2000" dirty="0"/>
+            <a:endParaRPr lang="en-US" sz="2200" dirty="0"/>
           </a:p>
           <a:p>
             <a:pPr marL="279400" indent="-279400">
@@ -3417,7 +3417,7 @@
               <a:buChar char="•"/>
             </a:pPr>
             <a:r>
-              <a:rPr lang="en-US" sz="2000" dirty="0">
+              <a:rPr lang="en-US" sz="2200" dirty="0">
                 <a:solidFill>
                   <a:srgbClr val="2E4450"/>
                 </a:solidFill>
@@ -3427,7 +3427,7 @@
               </a:rPr>
               <a:t>It covers daily harbour operations, vessels, crew, incidents, inspections, port companies, billing and reports.</a:t>
             </a:r>
-            <a:endParaRPr lang="en-US" sz="2000" dirty="0"/>
+            <a:endParaRPr lang="en-US" sz="2200" dirty="0"/>
           </a:p>
           <a:p>
             <a:pPr marL="279400" indent="-279400">
@@ -3438,7 +3438,7 @@
               <a:buChar char="•"/>
             </a:pPr>
             <a:r>
-              <a:rPr lang="en-US" sz="2000" dirty="0">
+              <a:rPr lang="en-US" sz="2200" dirty="0">
                 <a:solidFill>
                   <a:srgbClr val="2E4450"/>
                 </a:solidFill>
@@ -3448,7 +3448,7 @@
               </a:rPr>
               <a:t>It is already built and running. This deck is just pictures of it.</a:t>
             </a:r>
-            <a:endParaRPr lang="en-US" sz="2000" dirty="0"/>
+            <a:endParaRPr lang="en-US" sz="2200" dirty="0"/>
           </a:p>
         </p:txBody>
       </p:sp>
@@ -3535,8 +3535,8 @@
         </p:nvSpPr>
         <p:spPr>
           <a:xfrm>
-            <a:off x="1261872" y="329184"/>
-            <a:ext cx="10426903" cy="676656"/>
+            <a:off x="1261872" y="274320"/>
+            <a:ext cx="10426903" cy="804672"/>
           </a:xfrm>
           <a:prstGeom prst="rect">
             <a:avLst/>
@@ -3552,7 +3552,7 @@
               <a:buNone/>
             </a:pPr>
             <a:r>
-              <a:rPr lang="en-US" sz="2100" b="1" dirty="0">
+              <a:rPr lang="en-US" sz="2300" b="1" dirty="0">
                 <a:solidFill>
                   <a:srgbClr val="15242E"/>
                 </a:solidFill>
@@ -3562,7 +3562,7 @@
               </a:rPr>
               <a:t>Sign in once — each person sees only the applications their role needs.</a:t>
             </a:r>
-            <a:endParaRPr lang="en-US" sz="2100" dirty="0"/>
+            <a:endParaRPr lang="en-US" sz="2300" dirty="0"/>
           </a:p>
         </p:txBody>
       </p:sp>
@@ -3574,7 +3574,7 @@
         </p:nvSpPr>
         <p:spPr>
           <a:xfrm>
-            <a:off x="1280160" y="987552"/>
+            <a:off x="1280160" y="1097280"/>
             <a:ext cx="2011680" cy="41148"/>
           </a:xfrm>
           <a:prstGeom prst="rect">
@@ -3602,8 +3602,8 @@
         </p:blipFill>
         <p:spPr>
           <a:xfrm>
-            <a:off x="1706728" y="1143000"/>
-            <a:ext cx="8778240" cy="5486400"/>
+            <a:off x="1779880" y="1261872"/>
+            <a:ext cx="8631936" cy="5394960"/>
           </a:xfrm>
           <a:prstGeom prst="ellipse">
             <a:avLst/>
@@ -3700,8 +3700,8 @@
         </p:nvSpPr>
         <p:spPr>
           <a:xfrm>
-            <a:off x="1261872" y="329184"/>
-            <a:ext cx="10426903" cy="676656"/>
+            <a:off x="1261872" y="274320"/>
+            <a:ext cx="10426903" cy="804672"/>
           </a:xfrm>
           <a:prstGeom prst="rect">
             <a:avLst/>
@@ -3717,7 +3717,7 @@
               <a:buNone/>
             </a:pPr>
             <a:r>
-              <a:rPr lang="en-US" sz="2100" b="1" dirty="0">
+              <a:rPr lang="en-US" sz="2300" b="1" dirty="0">
                 <a:solidFill>
                   <a:srgbClr val="15242E"/>
                 </a:solidFill>
@@ -3727,7 +3727,7 @@
               </a:rPr>
               <a:t>The whole port on one screen, the moment you sign in.</a:t>
             </a:r>
-            <a:endParaRPr lang="en-US" sz="2100" dirty="0"/>
+            <a:endParaRPr lang="en-US" sz="2300" dirty="0"/>
           </a:p>
         </p:txBody>
       </p:sp>
@@ -3739,7 +3739,7 @@
         </p:nvSpPr>
         <p:spPr>
           <a:xfrm>
-            <a:off x="1280160" y="987552"/>
+            <a:off x="1280160" y="1097280"/>
             <a:ext cx="2011680" cy="41148"/>
           </a:xfrm>
           <a:prstGeom prst="rect">
@@ -3767,8 +3767,8 @@
         </p:blipFill>
         <p:spPr>
           <a:xfrm>
-            <a:off x="1706728" y="1143000"/>
-            <a:ext cx="8778240" cy="5486400"/>
+            <a:off x="1779880" y="1261872"/>
+            <a:ext cx="8631936" cy="5394960"/>
           </a:xfrm>
           <a:prstGeom prst="ellipse">
             <a:avLst/>
@@ -3865,8 +3865,8 @@
         </p:nvSpPr>
         <p:spPr>
           <a:xfrm>
-            <a:off x="1261872" y="329184"/>
-            <a:ext cx="10426903" cy="676656"/>
+            <a:off x="1261872" y="274320"/>
+            <a:ext cx="10426903" cy="804672"/>
           </a:xfrm>
           <a:prstGeom prst="rect">
             <a:avLst/>
@@ -3882,7 +3882,7 @@
               <a:buNone/>
             </a:pPr>
             <a:r>
-              <a:rPr lang="en-US" sz="2100" b="1" dirty="0">
+              <a:rPr lang="en-US" sz="2300" b="1" dirty="0">
                 <a:solidFill>
                   <a:srgbClr val="15242E"/>
                 </a:solidFill>
@@ -3892,7 +3892,7 @@
               </a:rPr>
               <a:t>Every berth and every vessel — who is where, right now.</a:t>
             </a:r>
-            <a:endParaRPr lang="en-US" sz="2100" dirty="0"/>
+            <a:endParaRPr lang="en-US" sz="2300" dirty="0"/>
           </a:p>
         </p:txBody>
       </p:sp>
@@ -3904,7 +3904,7 @@
         </p:nvSpPr>
         <p:spPr>
           <a:xfrm>
-            <a:off x="1280160" y="987552"/>
+            <a:off x="1280160" y="1097280"/>
             <a:ext cx="2011680" cy="41148"/>
           </a:xfrm>
           <a:prstGeom prst="rect">
@@ -3932,8 +3932,8 @@
         </p:blipFill>
         <p:spPr>
           <a:xfrm>
-            <a:off x="1706728" y="1143000"/>
-            <a:ext cx="8778240" cy="5486400"/>
+            <a:off x="1779880" y="1261872"/>
+            <a:ext cx="8631936" cy="5394960"/>
           </a:xfrm>
           <a:prstGeom prst="ellipse">
             <a:avLst/>
@@ -4030,8 +4030,8 @@
         </p:nvSpPr>
         <p:spPr>
           <a:xfrm>
-            <a:off x="1261872" y="329184"/>
-            <a:ext cx="10426903" cy="676656"/>
+            <a:off x="1261872" y="274320"/>
+            <a:ext cx="10426903" cy="804672"/>
           </a:xfrm>
           <a:prstGeom prst="rect">
             <a:avLst/>
@@ -4047,7 +4047,7 @@
               <a:buNone/>
             </a:pPr>
             <a:r>
-              <a:rPr lang="en-US" sz="2100" b="1" dirty="0">
+              <a:rPr lang="en-US" sz="2300" b="1" dirty="0">
                 <a:solidFill>
                   <a:srgbClr val="15242E"/>
                 </a:solidFill>
@@ -4057,7 +4057,7 @@
               </a:rPr>
               <a:t>The daily berthing report you already publish — generated automatically.</a:t>
             </a:r>
-            <a:endParaRPr lang="en-US" sz="2100" dirty="0"/>
+            <a:endParaRPr lang="en-US" sz="2300" dirty="0"/>
           </a:p>
         </p:txBody>
       </p:sp>
@@ -4069,7 +4069,7 @@
         </p:nvSpPr>
         <p:spPr>
           <a:xfrm>
-            <a:off x="1280160" y="987552"/>
+            <a:off x="1280160" y="1097280"/>
             <a:ext cx="2011680" cy="41148"/>
           </a:xfrm>
           <a:prstGeom prst="rect">
@@ -4097,8 +4097,8 @@
         </p:blipFill>
         <p:spPr>
           <a:xfrm>
-            <a:off x="1706728" y="1143000"/>
-            <a:ext cx="8778240" cy="5486400"/>
+            <a:off x="1779880" y="1261872"/>
+            <a:ext cx="8631936" cy="5394960"/>
           </a:xfrm>
           <a:prstGeom prst="ellipse">
             <a:avLst/>
@@ -4195,8 +4195,8 @@
         </p:nvSpPr>
         <p:spPr>
           <a:xfrm>
-            <a:off x="1261872" y="329184"/>
-            <a:ext cx="10426903" cy="676656"/>
+            <a:off x="1261872" y="274320"/>
+            <a:ext cx="10426903" cy="804672"/>
           </a:xfrm>
           <a:prstGeom prst="rect">
             <a:avLst/>
@@ -4212,7 +4212,7 @@
               <a:buNone/>
             </a:pPr>
             <a:r>
-              <a:rPr lang="en-US" sz="2100" b="1" dirty="0">
+              <a:rPr lang="en-US" sz="2300" b="1" dirty="0">
                 <a:solidFill>
                   <a:srgbClr val="15242E"/>
                 </a:solidFill>
@@ -4222,7 +4222,7 @@
               </a:rPr>
               <a:t>Twenty-four ready reports — Excel and PDF in one click.</a:t>
             </a:r>
-            <a:endParaRPr lang="en-US" sz="2100" dirty="0"/>
+            <a:endParaRPr lang="en-US" sz="2300" dirty="0"/>
           </a:p>
         </p:txBody>
       </p:sp>
@@ -4234,7 +4234,7 @@
         </p:nvSpPr>
         <p:spPr>
           <a:xfrm>
-            <a:off x="1280160" y="987552"/>
+            <a:off x="1280160" y="1097280"/>
             <a:ext cx="2011680" cy="41148"/>
           </a:xfrm>
           <a:prstGeom prst="rect">
@@ -4262,8 +4262,8 @@
         </p:blipFill>
         <p:spPr>
           <a:xfrm>
-            <a:off x="1706728" y="1143000"/>
-            <a:ext cx="8778240" cy="5486400"/>
+            <a:off x="1779880" y="1261872"/>
+            <a:ext cx="8631936" cy="5394960"/>
           </a:xfrm>
           <a:prstGeom prst="ellipse">
             <a:avLst/>
@@ -4360,8 +4360,8 @@
         </p:nvSpPr>
         <p:spPr>
           <a:xfrm>
-            <a:off x="1261872" y="329184"/>
-            <a:ext cx="10426903" cy="676656"/>
+            <a:off x="1261872" y="274320"/>
+            <a:ext cx="10426903" cy="804672"/>
           </a:xfrm>
           <a:prstGeom prst="rect">
             <a:avLst/>
@@ -4377,7 +4377,7 @@
               <a:buNone/>
             </a:pPr>
             <a:r>
-              <a:rPr lang="en-US" sz="2100" b="1" dirty="0">
+              <a:rPr lang="en-US" sz="2300" b="1" dirty="0">
                 <a:solidFill>
                   <a:srgbClr val="15242E"/>
                 </a:solidFill>
@@ -4387,7 +4387,7 @@
               </a:rPr>
               <a:t>Incidents become case files — reported, assigned, resolved, closed.</a:t>
             </a:r>
-            <a:endParaRPr lang="en-US" sz="2100" dirty="0"/>
+            <a:endParaRPr lang="en-US" sz="2300" dirty="0"/>
           </a:p>
         </p:txBody>
       </p:sp>
@@ -4399,7 +4399,7 @@
         </p:nvSpPr>
         <p:spPr>
           <a:xfrm>
-            <a:off x="1280160" y="987552"/>
+            <a:off x="1280160" y="1097280"/>
             <a:ext cx="2011680" cy="41148"/>
           </a:xfrm>
           <a:prstGeom prst="rect">
@@ -4427,8 +4427,8 @@
         </p:blipFill>
         <p:spPr>
           <a:xfrm>
-            <a:off x="1706728" y="1143000"/>
-            <a:ext cx="8778240" cy="5486400"/>
+            <a:off x="1779880" y="1261872"/>
+            <a:ext cx="8631936" cy="5394960"/>
           </a:xfrm>
           <a:prstGeom prst="ellipse">
             <a:avLst/>
@@ -4525,8 +4525,8 @@
         </p:nvSpPr>
         <p:spPr>
           <a:xfrm>
-            <a:off x="1261872" y="329184"/>
-            <a:ext cx="10426903" cy="676656"/>
+            <a:off x="1261872" y="274320"/>
+            <a:ext cx="10426903" cy="804672"/>
           </a:xfrm>
           <a:prstGeom prst="rect">
             <a:avLst/>
@@ -4542,7 +4542,7 @@
               <a:buNone/>
             </a:pPr>
             <a:r>
-              <a:rPr lang="en-US" sz="2100" b="1" dirty="0">
+              <a:rPr lang="en-US" sz="2300" b="1" dirty="0">
                 <a:solidFill>
                   <a:srgbClr val="15242E"/>
                 </a:solidFill>
@@ -4552,7 +4552,7 @@
               </a:rPr>
               <a:t>Inspections run on your own checklists — your team writes the questions.</a:t>
             </a:r>
-            <a:endParaRPr lang="en-US" sz="2100" dirty="0"/>
+            <a:endParaRPr lang="en-US" sz="2300" dirty="0"/>
           </a:p>
         </p:txBody>
       </p:sp>
@@ -4564,7 +4564,7 @@
         </p:nvSpPr>
         <p:spPr>
           <a:xfrm>
-            <a:off x="1280160" y="987552"/>
+            <a:off x="1280160" y="1097280"/>
             <a:ext cx="2011680" cy="41148"/>
           </a:xfrm>
           <a:prstGeom prst="rect">
@@ -4592,8 +4592,8 @@
         </p:blipFill>
         <p:spPr>
           <a:xfrm>
-            <a:off x="1706728" y="1143000"/>
-            <a:ext cx="8778240" cy="5486400"/>
+            <a:off x="1779880" y="1261872"/>
+            <a:ext cx="8631936" cy="5394960"/>
           </a:xfrm>
           <a:prstGeom prst="ellipse">
             <a:avLst/>

</xml_diff>